<commit_message>
Phase 2: self-test guide, fix configuration count (E1–E8 = 32), rebuild deck
Co-Authored-By: Claude Opus 5.5 <noreply@anthropic.com>
</commit_message>
<xml_diff>
--- a/phase2/MCP-TS-SDK-phase2.pptx
+++ b/phase2/MCP-TS-SDK-phase2.pptx
@@ -5549,7 +5549,7 @@
           <a:p>
             <a:r>
               <a:rPr lang="en-US" dirty="0"/>
-              <a:t>To conclude: thanks to MCP the same three servers served 27 configurations without changing server code. The parameters that matter are the ones that change what the model sees. And safety comes from the server design, not from hoping the model behaves. Thank you — questions are welcome.</a:t>
+              <a:t>To conclude: thanks to MCP the same three servers served 32 configurations without changing server code. The parameters that matter are the ones that change what the model sees. And safety comes from the server design, not from hoping the model behaves. Thank you — questions are welcome.</a:t>
             </a:r>
             <a:endParaRPr lang="en-US" dirty="0"/>
           </a:p>
@@ -6839,7 +6839,7 @@
                   <a:srgbClr val="C9D3E6"/>
                 </a:solidFill>
               </a:rPr>
-              <a:t>3 MCP servers · 22 tools · 24 scenarios · 8 experiments · 27 configurations · 522 logged LLM runs</a:t>
+              <a:t>3 MCP servers · 22 tools · 24 scenarios · 8 experiments · 32 configurations · 522 logged LLM runs</a:t>
             </a:r>
             <a:endParaRPr lang="en-US" sz="2000" dirty="0"/>
           </a:p>
@@ -34491,7 +34491,7 @@
                   <a:srgbClr val="FFFFFF"/>
                 </a:solidFill>
               </a:rPr>
-              <a:t>the same 3 servers answered 27 configurations without one line of server code changing.</a:t>
+              <a:t>the same 3 servers answered all 32 configurations of E1–E8 without one line of server code changing.</a:t>
             </a:r>
             <a:endParaRPr lang="en-US" sz="2000" dirty="0"/>
           </a:p>
@@ -39142,7 +39142,7 @@
                   <a:srgbClr val="C9D3E6"/>
                 </a:solidFill>
               </a:rPr>
-              <a:t>8 experiments · 27 configurations · one parameter changed at a time</a:t>
+              <a:t>8 experiments · 32 configurations · one parameter changed at a time</a:t>
             </a:r>
             <a:endParaRPr lang="en-US" sz="1800" dirty="0"/>
           </a:p>

</xml_diff>